<commit_message>
final touthcs in presentation
</commit_message>
<xml_diff>
--- a/Project/Presentation.pptx
+++ b/Project/Presentation.pptx
@@ -11,8 +11,8 @@
     <p:sldId id="275" r:id="rId5"/>
     <p:sldId id="274" r:id="rId6"/>
     <p:sldId id="276" r:id="rId7"/>
-    <p:sldId id="277" r:id="rId8"/>
-    <p:sldId id="279" r:id="rId9"/>
+    <p:sldId id="279" r:id="rId8"/>
+    <p:sldId id="277" r:id="rId9"/>
     <p:sldId id="278" r:id="rId10"/>
     <p:sldId id="280" r:id="rId11"/>
     <p:sldId id="281" r:id="rId12"/>
@@ -117,7 +117,581 @@
       </a:defRPr>
     </a:lvl9pPr>
   </p:defaultTextStyle>
+  <p:extLst>
+    <p:ext uri="{EFAFB233-063F-42B5-8137-9DF3F51BA10A}">
+      <p15:sldGuideLst xmlns:p15="http://schemas.microsoft.com/office/powerpoint/2012/main"/>
+    </p:ext>
+  </p:extLst>
 </p:presentation>
+</file>
+
+<file path=ppt/revisionInfo.xml><?xml version="1.0" encoding="utf-8"?>
+<p1510:revInfo xmlns:a="http://schemas.openxmlformats.org/drawingml/2006/main" xmlns:r="http://schemas.openxmlformats.org/officeDocument/2006/relationships" xmlns:p1510="http://schemas.microsoft.com/office/powerpoint/2015/10/main">
+  <p1510:revLst>
+    <p1510:client id="{1143B687-A76E-441B-8A0A-9907776C011C}" v="19" dt="2025-10-22T01:05:51.164"/>
+  </p1510:revLst>
+</p1510:revInfo>
+</file>
+
+<file path=ppt/changesInfos/changesInfo1.xml><?xml version="1.0" encoding="utf-8"?>
+<pc:chgInfo xmlns:a="http://schemas.openxmlformats.org/drawingml/2006/main" xmlns:r="http://schemas.openxmlformats.org/officeDocument/2006/relationships" xmlns:ac="http://schemas.microsoft.com/office/drawing/2013/main/command" xmlns:pc="http://schemas.microsoft.com/office/powerpoint/2013/main/command">
+  <pc:docChgLst>
+    <pc:chgData name="Afonso Duarte" userId="f1a960851f587191" providerId="LiveId" clId="{46D14D1A-50E6-400A-8836-C64EDA333A06}"/>
+    <pc:docChg chg="undo custSel modSld sldOrd">
+      <pc:chgData name="Afonso Duarte" userId="f1a960851f587191" providerId="LiveId" clId="{46D14D1A-50E6-400A-8836-C64EDA333A06}" dt="2025-10-22T01:05:56.120" v="73" actId="1076"/>
+      <pc:docMkLst>
+        <pc:docMk/>
+      </pc:docMkLst>
+      <pc:sldChg chg="modSp mod">
+        <pc:chgData name="Afonso Duarte" userId="f1a960851f587191" providerId="LiveId" clId="{46D14D1A-50E6-400A-8836-C64EDA333A06}" dt="2025-10-22T00:40:52.352" v="23" actId="790"/>
+        <pc:sldMkLst>
+          <pc:docMk/>
+          <pc:sldMk cId="2020280425" sldId="272"/>
+        </pc:sldMkLst>
+        <pc:spChg chg="mod">
+          <ac:chgData name="Afonso Duarte" userId="f1a960851f587191" providerId="LiveId" clId="{46D14D1A-50E6-400A-8836-C64EDA333A06}" dt="2025-10-22T00:40:52.352" v="23" actId="790"/>
+          <ac:spMkLst>
+            <pc:docMk/>
+            <pc:sldMk cId="2020280425" sldId="272"/>
+            <ac:spMk id="2" creationId="{00000000-0000-0000-0000-000000000000}"/>
+          </ac:spMkLst>
+        </pc:spChg>
+        <pc:spChg chg="mod">
+          <ac:chgData name="Afonso Duarte" userId="f1a960851f587191" providerId="LiveId" clId="{46D14D1A-50E6-400A-8836-C64EDA333A06}" dt="2025-10-22T00:40:52.352" v="23" actId="790"/>
+          <ac:spMkLst>
+            <pc:docMk/>
+            <pc:sldMk cId="2020280425" sldId="272"/>
+            <ac:spMk id="3" creationId="{00000000-0000-0000-0000-000000000000}"/>
+          </ac:spMkLst>
+        </pc:spChg>
+        <pc:spChg chg="mod">
+          <ac:chgData name="Afonso Duarte" userId="f1a960851f587191" providerId="LiveId" clId="{46D14D1A-50E6-400A-8836-C64EDA333A06}" dt="2025-10-22T00:40:52.352" v="23" actId="790"/>
+          <ac:spMkLst>
+            <pc:docMk/>
+            <pc:sldMk cId="2020280425" sldId="272"/>
+            <ac:spMk id="10" creationId="{E91DC736-0EF8-4F87-9146-EBF1D2EE4D3D}"/>
+          </ac:spMkLst>
+        </pc:spChg>
+        <pc:spChg chg="mod">
+          <ac:chgData name="Afonso Duarte" userId="f1a960851f587191" providerId="LiveId" clId="{46D14D1A-50E6-400A-8836-C64EDA333A06}" dt="2025-10-22T00:40:52.352" v="23" actId="790"/>
+          <ac:spMkLst>
+            <pc:docMk/>
+            <pc:sldMk cId="2020280425" sldId="272"/>
+            <ac:spMk id="12" creationId="{097CD68E-23E3-4007-8847-CD0944C4F7BE}"/>
+          </ac:spMkLst>
+        </pc:spChg>
+        <pc:spChg chg="mod">
+          <ac:chgData name="Afonso Duarte" userId="f1a960851f587191" providerId="LiveId" clId="{46D14D1A-50E6-400A-8836-C64EDA333A06}" dt="2025-10-22T00:40:52.352" v="23" actId="790"/>
+          <ac:spMkLst>
+            <pc:docMk/>
+            <pc:sldMk cId="2020280425" sldId="272"/>
+            <ac:spMk id="14" creationId="{AF2F604E-43BE-4DC3-B983-E071523364F8}"/>
+          </ac:spMkLst>
+        </pc:spChg>
+        <pc:spChg chg="mod">
+          <ac:chgData name="Afonso Duarte" userId="f1a960851f587191" providerId="LiveId" clId="{46D14D1A-50E6-400A-8836-C64EDA333A06}" dt="2025-10-22T00:40:52.352" v="23" actId="790"/>
+          <ac:spMkLst>
+            <pc:docMk/>
+            <pc:sldMk cId="2020280425" sldId="272"/>
+            <ac:spMk id="16" creationId="{08C9B587-E65E-4B52-B37C-ABEBB6E87928}"/>
+          </ac:spMkLst>
+        </pc:spChg>
+      </pc:sldChg>
+      <pc:sldChg chg="addSp delSp modSp mod">
+        <pc:chgData name="Afonso Duarte" userId="f1a960851f587191" providerId="LiveId" clId="{46D14D1A-50E6-400A-8836-C64EDA333A06}" dt="2025-10-22T00:43:45.118" v="44" actId="12"/>
+        <pc:sldMkLst>
+          <pc:docMk/>
+          <pc:sldMk cId="1798169863" sldId="273"/>
+        </pc:sldMkLst>
+        <pc:spChg chg="mod">
+          <ac:chgData name="Afonso Duarte" userId="f1a960851f587191" providerId="LiveId" clId="{46D14D1A-50E6-400A-8836-C64EDA333A06}" dt="2025-10-22T00:40:52.352" v="23" actId="790"/>
+          <ac:spMkLst>
+            <pc:docMk/>
+            <pc:sldMk cId="1798169863" sldId="273"/>
+            <ac:spMk id="2" creationId="{FD222B08-DEAD-E5F1-A944-162AA4640FD2}"/>
+          </ac:spMkLst>
+        </pc:spChg>
+        <pc:spChg chg="del mod">
+          <ac:chgData name="Afonso Duarte" userId="f1a960851f587191" providerId="LiveId" clId="{46D14D1A-50E6-400A-8836-C64EDA333A06}" dt="2025-10-22T00:39:54.502" v="3" actId="478"/>
+          <ac:spMkLst>
+            <pc:docMk/>
+            <pc:sldMk cId="1798169863" sldId="273"/>
+            <ac:spMk id="3" creationId="{367486E0-D9DD-4D28-00B3-822B9182BF98}"/>
+          </ac:spMkLst>
+        </pc:spChg>
+        <pc:spChg chg="add mod">
+          <ac:chgData name="Afonso Duarte" userId="f1a960851f587191" providerId="LiveId" clId="{46D14D1A-50E6-400A-8836-C64EDA333A06}" dt="2025-10-22T00:43:45.118" v="44" actId="12"/>
+          <ac:spMkLst>
+            <pc:docMk/>
+            <pc:sldMk cId="1798169863" sldId="273"/>
+            <ac:spMk id="4" creationId="{6AB95D55-7CA9-D1F0-4654-17A4E24B2008}"/>
+          </ac:spMkLst>
+        </pc:spChg>
+        <pc:spChg chg="add del mod">
+          <ac:chgData name="Afonso Duarte" userId="f1a960851f587191" providerId="LiveId" clId="{46D14D1A-50E6-400A-8836-C64EDA333A06}" dt="2025-10-22T00:39:58.272" v="4" actId="478"/>
+          <ac:spMkLst>
+            <pc:docMk/>
+            <pc:sldMk cId="1798169863" sldId="273"/>
+            <ac:spMk id="6" creationId="{411AF290-815C-A2B6-FEAD-F926B62C848B}"/>
+          </ac:spMkLst>
+        </pc:spChg>
+        <pc:spChg chg="mod">
+          <ac:chgData name="Afonso Duarte" userId="f1a960851f587191" providerId="LiveId" clId="{46D14D1A-50E6-400A-8836-C64EDA333A06}" dt="2025-10-22T00:40:52.352" v="23" actId="790"/>
+          <ac:spMkLst>
+            <pc:docMk/>
+            <pc:sldMk cId="1798169863" sldId="273"/>
+            <ac:spMk id="8" creationId="{DAF1966E-FD40-4A4A-B61B-C4DF7FA05F06}"/>
+          </ac:spMkLst>
+        </pc:spChg>
+        <pc:spChg chg="mod">
+          <ac:chgData name="Afonso Duarte" userId="f1a960851f587191" providerId="LiveId" clId="{46D14D1A-50E6-400A-8836-C64EDA333A06}" dt="2025-10-22T00:40:52.352" v="23" actId="790"/>
+          <ac:spMkLst>
+            <pc:docMk/>
+            <pc:sldMk cId="1798169863" sldId="273"/>
+            <ac:spMk id="10" creationId="{047BFA19-D45E-416B-A404-7AF2F3F27017}"/>
+          </ac:spMkLst>
+        </pc:spChg>
+        <pc:spChg chg="mod">
+          <ac:chgData name="Afonso Duarte" userId="f1a960851f587191" providerId="LiveId" clId="{46D14D1A-50E6-400A-8836-C64EDA333A06}" dt="2025-10-22T00:40:52.352" v="23" actId="790"/>
+          <ac:spMkLst>
+            <pc:docMk/>
+            <pc:sldMk cId="1798169863" sldId="273"/>
+            <ac:spMk id="12" creationId="{8E0105E7-23DB-4CF2-8258-FF47C7620F6E}"/>
+          </ac:spMkLst>
+        </pc:spChg>
+        <pc:spChg chg="mod">
+          <ac:chgData name="Afonso Duarte" userId="f1a960851f587191" providerId="LiveId" clId="{46D14D1A-50E6-400A-8836-C64EDA333A06}" dt="2025-10-22T00:40:52.352" v="23" actId="790"/>
+          <ac:spMkLst>
+            <pc:docMk/>
+            <pc:sldMk cId="1798169863" sldId="273"/>
+            <ac:spMk id="14" creationId="{074B4F7D-14B2-478B-8BF5-01E4E0C5D263}"/>
+          </ac:spMkLst>
+        </pc:spChg>
+      </pc:sldChg>
+      <pc:sldChg chg="modSp mod">
+        <pc:chgData name="Afonso Duarte" userId="f1a960851f587191" providerId="LiveId" clId="{46D14D1A-50E6-400A-8836-C64EDA333A06}" dt="2025-10-22T00:50:23.579" v="57" actId="1076"/>
+        <pc:sldMkLst>
+          <pc:docMk/>
+          <pc:sldMk cId="2859347578" sldId="274"/>
+        </pc:sldMkLst>
+        <pc:spChg chg="mod">
+          <ac:chgData name="Afonso Duarte" userId="f1a960851f587191" providerId="LiveId" clId="{46D14D1A-50E6-400A-8836-C64EDA333A06}" dt="2025-10-22T00:40:52.352" v="23" actId="790"/>
+          <ac:spMkLst>
+            <pc:docMk/>
+            <pc:sldMk cId="2859347578" sldId="274"/>
+            <ac:spMk id="2" creationId="{572465C3-7E3A-EB6F-54D6-AFC9C31686C4}"/>
+          </ac:spMkLst>
+        </pc:spChg>
+        <pc:spChg chg="mod">
+          <ac:chgData name="Afonso Duarte" userId="f1a960851f587191" providerId="LiveId" clId="{46D14D1A-50E6-400A-8836-C64EDA333A06}" dt="2025-10-22T00:40:52.352" v="23" actId="790"/>
+          <ac:spMkLst>
+            <pc:docMk/>
+            <pc:sldMk cId="2859347578" sldId="274"/>
+            <ac:spMk id="16" creationId="{25549E48-55B4-43FA-96F3-A3F777E0F295}"/>
+          </ac:spMkLst>
+        </pc:spChg>
+        <pc:spChg chg="mod">
+          <ac:chgData name="Afonso Duarte" userId="f1a960851f587191" providerId="LiveId" clId="{46D14D1A-50E6-400A-8836-C64EDA333A06}" dt="2025-10-22T00:40:52.352" v="23" actId="790"/>
+          <ac:spMkLst>
+            <pc:docMk/>
+            <pc:sldMk cId="2859347578" sldId="274"/>
+            <ac:spMk id="18" creationId="{0ADDB668-2CA4-4D2B-9C34-3487CA330BA8}"/>
+          </ac:spMkLst>
+        </pc:spChg>
+        <pc:spChg chg="mod">
+          <ac:chgData name="Afonso Duarte" userId="f1a960851f587191" providerId="LiveId" clId="{46D14D1A-50E6-400A-8836-C64EDA333A06}" dt="2025-10-22T00:40:52.352" v="23" actId="790"/>
+          <ac:spMkLst>
+            <pc:docMk/>
+            <pc:sldMk cId="2859347578" sldId="274"/>
+            <ac:spMk id="20" creationId="{2568BC19-F052-4108-93E1-6A3D1DEC072F}"/>
+          </ac:spMkLst>
+        </pc:spChg>
+        <pc:spChg chg="mod">
+          <ac:chgData name="Afonso Duarte" userId="f1a960851f587191" providerId="LiveId" clId="{46D14D1A-50E6-400A-8836-C64EDA333A06}" dt="2025-10-22T00:40:52.352" v="23" actId="790"/>
+          <ac:spMkLst>
+            <pc:docMk/>
+            <pc:sldMk cId="2859347578" sldId="274"/>
+            <ac:spMk id="22" creationId="{D5FD337D-4D6B-4C8B-B6F5-121097E09881}"/>
+          </ac:spMkLst>
+        </pc:spChg>
+        <pc:picChg chg="mod">
+          <ac:chgData name="Afonso Duarte" userId="f1a960851f587191" providerId="LiveId" clId="{46D14D1A-50E6-400A-8836-C64EDA333A06}" dt="2025-10-22T00:50:19.676" v="54" actId="14100"/>
+          <ac:picMkLst>
+            <pc:docMk/>
+            <pc:sldMk cId="2859347578" sldId="274"/>
+            <ac:picMk id="9" creationId="{660A392F-C15E-20D7-7529-CA4A76CB8C9E}"/>
+          </ac:picMkLst>
+        </pc:picChg>
+        <pc:picChg chg="mod">
+          <ac:chgData name="Afonso Duarte" userId="f1a960851f587191" providerId="LiveId" clId="{46D14D1A-50E6-400A-8836-C64EDA333A06}" dt="2025-10-22T00:50:23.579" v="57" actId="1076"/>
+          <ac:picMkLst>
+            <pc:docMk/>
+            <pc:sldMk cId="2859347578" sldId="274"/>
+            <ac:picMk id="11" creationId="{ECF7BE14-BA60-512B-AEC1-5E379282C3E2}"/>
+          </ac:picMkLst>
+        </pc:picChg>
+      </pc:sldChg>
+      <pc:sldChg chg="modSp mod">
+        <pc:chgData name="Afonso Duarte" userId="f1a960851f587191" providerId="LiveId" clId="{46D14D1A-50E6-400A-8836-C64EDA333A06}" dt="2025-10-22T00:50:00.861" v="52" actId="20577"/>
+        <pc:sldMkLst>
+          <pc:docMk/>
+          <pc:sldMk cId="3573676320" sldId="275"/>
+        </pc:sldMkLst>
+        <pc:spChg chg="mod">
+          <ac:chgData name="Afonso Duarte" userId="f1a960851f587191" providerId="LiveId" clId="{46D14D1A-50E6-400A-8836-C64EDA333A06}" dt="2025-10-22T00:40:52.352" v="23" actId="790"/>
+          <ac:spMkLst>
+            <pc:docMk/>
+            <pc:sldMk cId="3573676320" sldId="275"/>
+            <ac:spMk id="2" creationId="{17700F77-C983-E78F-464C-4B16AF9A2717}"/>
+          </ac:spMkLst>
+        </pc:spChg>
+        <pc:spChg chg="mod">
+          <ac:chgData name="Afonso Duarte" userId="f1a960851f587191" providerId="LiveId" clId="{46D14D1A-50E6-400A-8836-C64EDA333A06}" dt="2025-10-22T00:50:00.861" v="52" actId="20577"/>
+          <ac:spMkLst>
+            <pc:docMk/>
+            <pc:sldMk cId="3573676320" sldId="275"/>
+            <ac:spMk id="3" creationId="{A28F8F23-E1A5-5801-FDDF-58691AB6F06A}"/>
+          </ac:spMkLst>
+        </pc:spChg>
+        <pc:spChg chg="mod">
+          <ac:chgData name="Afonso Duarte" userId="f1a960851f587191" providerId="LiveId" clId="{46D14D1A-50E6-400A-8836-C64EDA333A06}" dt="2025-10-22T00:40:52.352" v="23" actId="790"/>
+          <ac:spMkLst>
+            <pc:docMk/>
+            <pc:sldMk cId="3573676320" sldId="275"/>
+            <ac:spMk id="8" creationId="{2029D5AD-8348-4446-B191-6A9B6FE03F21}"/>
+          </ac:spMkLst>
+        </pc:spChg>
+        <pc:spChg chg="mod">
+          <ac:chgData name="Afonso Duarte" userId="f1a960851f587191" providerId="LiveId" clId="{46D14D1A-50E6-400A-8836-C64EDA333A06}" dt="2025-10-22T00:40:52.352" v="23" actId="790"/>
+          <ac:spMkLst>
+            <pc:docMk/>
+            <pc:sldMk cId="3573676320" sldId="275"/>
+            <ac:spMk id="10" creationId="{A3F395A2-2B64-4749-BD93-2F159C7E1FB5}"/>
+          </ac:spMkLst>
+        </pc:spChg>
+        <pc:spChg chg="mod">
+          <ac:chgData name="Afonso Duarte" userId="f1a960851f587191" providerId="LiveId" clId="{46D14D1A-50E6-400A-8836-C64EDA333A06}" dt="2025-10-22T00:40:52.352" v="23" actId="790"/>
+          <ac:spMkLst>
+            <pc:docMk/>
+            <pc:sldMk cId="3573676320" sldId="275"/>
+            <ac:spMk id="12" creationId="{5CF0135B-EAB8-4CA0-896C-2D897ECD28BC}"/>
+          </ac:spMkLst>
+        </pc:spChg>
+        <pc:spChg chg="mod">
+          <ac:chgData name="Afonso Duarte" userId="f1a960851f587191" providerId="LiveId" clId="{46D14D1A-50E6-400A-8836-C64EDA333A06}" dt="2025-10-22T00:40:52.352" v="23" actId="790"/>
+          <ac:spMkLst>
+            <pc:docMk/>
+            <pc:sldMk cId="3573676320" sldId="275"/>
+            <ac:spMk id="14" creationId="{92C3387C-D24F-4737-8A37-1DC5CFF09CFA}"/>
+          </ac:spMkLst>
+        </pc:spChg>
+      </pc:sldChg>
+      <pc:sldChg chg="modSp mod">
+        <pc:chgData name="Afonso Duarte" userId="f1a960851f587191" providerId="LiveId" clId="{46D14D1A-50E6-400A-8836-C64EDA333A06}" dt="2025-10-22T00:40:52.352" v="23" actId="790"/>
+        <pc:sldMkLst>
+          <pc:docMk/>
+          <pc:sldMk cId="3386540730" sldId="276"/>
+        </pc:sldMkLst>
+        <pc:spChg chg="mod">
+          <ac:chgData name="Afonso Duarte" userId="f1a960851f587191" providerId="LiveId" clId="{46D14D1A-50E6-400A-8836-C64EDA333A06}" dt="2025-10-22T00:40:52.352" v="23" actId="790"/>
+          <ac:spMkLst>
+            <pc:docMk/>
+            <pc:sldMk cId="3386540730" sldId="276"/>
+            <ac:spMk id="2" creationId="{3E043E32-D948-1FD5-E096-008F5AFAC8EC}"/>
+          </ac:spMkLst>
+        </pc:spChg>
+        <pc:spChg chg="mod">
+          <ac:chgData name="Afonso Duarte" userId="f1a960851f587191" providerId="LiveId" clId="{46D14D1A-50E6-400A-8836-C64EDA333A06}" dt="2025-10-22T00:40:52.352" v="23" actId="790"/>
+          <ac:spMkLst>
+            <pc:docMk/>
+            <pc:sldMk cId="3386540730" sldId="276"/>
+            <ac:spMk id="12" creationId="{68AF5748-FED8-45BA-8631-26D1D10F3246}"/>
+          </ac:spMkLst>
+        </pc:spChg>
+        <pc:spChg chg="mod">
+          <ac:chgData name="Afonso Duarte" userId="f1a960851f587191" providerId="LiveId" clId="{46D14D1A-50E6-400A-8836-C64EDA333A06}" dt="2025-10-22T00:40:52.352" v="23" actId="790"/>
+          <ac:spMkLst>
+            <pc:docMk/>
+            <pc:sldMk cId="3386540730" sldId="276"/>
+            <ac:spMk id="13" creationId="{B5CCED56-55A9-7071-F8D6-6D26E378BB54}"/>
+          </ac:spMkLst>
+        </pc:spChg>
+        <pc:spChg chg="mod">
+          <ac:chgData name="Afonso Duarte" userId="f1a960851f587191" providerId="LiveId" clId="{46D14D1A-50E6-400A-8836-C64EDA333A06}" dt="2025-10-22T00:40:52.352" v="23" actId="790"/>
+          <ac:spMkLst>
+            <pc:docMk/>
+            <pc:sldMk cId="3386540730" sldId="276"/>
+            <ac:spMk id="14" creationId="{AF2F604E-43BE-4DC3-B983-E071523364F8}"/>
+          </ac:spMkLst>
+        </pc:spChg>
+        <pc:spChg chg="mod">
+          <ac:chgData name="Afonso Duarte" userId="f1a960851f587191" providerId="LiveId" clId="{46D14D1A-50E6-400A-8836-C64EDA333A06}" dt="2025-10-22T00:40:52.352" v="23" actId="790"/>
+          <ac:spMkLst>
+            <pc:docMk/>
+            <pc:sldMk cId="3386540730" sldId="276"/>
+            <ac:spMk id="16" creationId="{08C9B587-E65E-4B52-B37C-ABEBB6E87928}"/>
+          </ac:spMkLst>
+        </pc:spChg>
+        <pc:spChg chg="mod">
+          <ac:chgData name="Afonso Duarte" userId="f1a960851f587191" providerId="LiveId" clId="{46D14D1A-50E6-400A-8836-C64EDA333A06}" dt="2025-10-22T00:40:52.352" v="23" actId="790"/>
+          <ac:spMkLst>
+            <pc:docMk/>
+            <pc:sldMk cId="3386540730" sldId="276"/>
+            <ac:spMk id="17" creationId="{B1877DC6-77D9-669C-DD05-8F09ECB71E96}"/>
+          </ac:spMkLst>
+        </pc:spChg>
+      </pc:sldChg>
+      <pc:sldChg chg="modSp mod">
+        <pc:chgData name="Afonso Duarte" userId="f1a960851f587191" providerId="LiveId" clId="{46D14D1A-50E6-400A-8836-C64EDA333A06}" dt="2025-10-22T01:04:01.324" v="66" actId="20577"/>
+        <pc:sldMkLst>
+          <pc:docMk/>
+          <pc:sldMk cId="3403054834" sldId="277"/>
+        </pc:sldMkLst>
+        <pc:spChg chg="mod">
+          <ac:chgData name="Afonso Duarte" userId="f1a960851f587191" providerId="LiveId" clId="{46D14D1A-50E6-400A-8836-C64EDA333A06}" dt="2025-10-22T00:40:52.352" v="23" actId="790"/>
+          <ac:spMkLst>
+            <pc:docMk/>
+            <pc:sldMk cId="3403054834" sldId="277"/>
+            <ac:spMk id="2" creationId="{9D751291-12F3-6270-C31E-1818E8DD6EB3}"/>
+          </ac:spMkLst>
+        </pc:spChg>
+        <pc:spChg chg="mod">
+          <ac:chgData name="Afonso Duarte" userId="f1a960851f587191" providerId="LiveId" clId="{46D14D1A-50E6-400A-8836-C64EDA333A06}" dt="2025-10-22T00:40:52.352" v="23" actId="790"/>
+          <ac:spMkLst>
+            <pc:docMk/>
+            <pc:sldMk cId="3403054834" sldId="277"/>
+            <ac:spMk id="4" creationId="{539F5613-7FF4-F7F6-7C43-CF0FA77249D3}"/>
+          </ac:spMkLst>
+        </pc:spChg>
+        <pc:spChg chg="mod">
+          <ac:chgData name="Afonso Duarte" userId="f1a960851f587191" providerId="LiveId" clId="{46D14D1A-50E6-400A-8836-C64EDA333A06}" dt="2025-10-22T01:04:01.324" v="66" actId="20577"/>
+          <ac:spMkLst>
+            <pc:docMk/>
+            <pc:sldMk cId="3403054834" sldId="277"/>
+            <ac:spMk id="11" creationId="{ABA8A5C0-E552-7235-000A-E2311CB3CCE0}"/>
+          </ac:spMkLst>
+        </pc:spChg>
+      </pc:sldChg>
+      <pc:sldChg chg="modSp mod">
+        <pc:chgData name="Afonso Duarte" userId="f1a960851f587191" providerId="LiveId" clId="{46D14D1A-50E6-400A-8836-C64EDA333A06}" dt="2025-10-22T01:04:19.443" v="68" actId="1076"/>
+        <pc:sldMkLst>
+          <pc:docMk/>
+          <pc:sldMk cId="3329660005" sldId="278"/>
+        </pc:sldMkLst>
+        <pc:spChg chg="mod">
+          <ac:chgData name="Afonso Duarte" userId="f1a960851f587191" providerId="LiveId" clId="{46D14D1A-50E6-400A-8836-C64EDA333A06}" dt="2025-10-22T00:40:52.352" v="23" actId="790"/>
+          <ac:spMkLst>
+            <pc:docMk/>
+            <pc:sldMk cId="3329660005" sldId="278"/>
+            <ac:spMk id="2" creationId="{2B0AD053-B18E-0C69-4C59-E396B02BAA4D}"/>
+          </ac:spMkLst>
+        </pc:spChg>
+        <pc:spChg chg="mod">
+          <ac:chgData name="Afonso Duarte" userId="f1a960851f587191" providerId="LiveId" clId="{46D14D1A-50E6-400A-8836-C64EDA333A06}" dt="2025-10-22T00:40:52.352" v="23" actId="790"/>
+          <ac:spMkLst>
+            <pc:docMk/>
+            <pc:sldMk cId="3329660005" sldId="278"/>
+            <ac:spMk id="4" creationId="{D8827F92-5E2A-2E2E-8740-54EB2FBFA872}"/>
+          </ac:spMkLst>
+        </pc:spChg>
+        <pc:spChg chg="mod">
+          <ac:chgData name="Afonso Duarte" userId="f1a960851f587191" providerId="LiveId" clId="{46D14D1A-50E6-400A-8836-C64EDA333A06}" dt="2025-10-22T01:04:19.443" v="68" actId="1076"/>
+          <ac:spMkLst>
+            <pc:docMk/>
+            <pc:sldMk cId="3329660005" sldId="278"/>
+            <ac:spMk id="7" creationId="{C8E7891F-A99F-D619-754B-879A802436C1}"/>
+          </ac:spMkLst>
+        </pc:spChg>
+      </pc:sldChg>
+      <pc:sldChg chg="modSp mod ord">
+        <pc:chgData name="Afonso Duarte" userId="f1a960851f587191" providerId="LiveId" clId="{46D14D1A-50E6-400A-8836-C64EDA333A06}" dt="2025-10-22T01:03:36.820" v="64" actId="948"/>
+        <pc:sldMkLst>
+          <pc:docMk/>
+          <pc:sldMk cId="3720105677" sldId="279"/>
+        </pc:sldMkLst>
+        <pc:spChg chg="mod">
+          <ac:chgData name="Afonso Duarte" userId="f1a960851f587191" providerId="LiveId" clId="{46D14D1A-50E6-400A-8836-C64EDA333A06}" dt="2025-10-22T00:40:52.352" v="23" actId="790"/>
+          <ac:spMkLst>
+            <pc:docMk/>
+            <pc:sldMk cId="3720105677" sldId="279"/>
+            <ac:spMk id="2" creationId="{05ED50FA-A298-9FE7-D884-3E2642F8AFA9}"/>
+          </ac:spMkLst>
+        </pc:spChg>
+        <pc:spChg chg="mod">
+          <ac:chgData name="Afonso Duarte" userId="f1a960851f587191" providerId="LiveId" clId="{46D14D1A-50E6-400A-8836-C64EDA333A06}" dt="2025-10-22T00:40:52.352" v="23" actId="790"/>
+          <ac:spMkLst>
+            <pc:docMk/>
+            <pc:sldMk cId="3720105677" sldId="279"/>
+            <ac:spMk id="4" creationId="{41567421-318E-11BE-B85E-09AC56258A33}"/>
+          </ac:spMkLst>
+        </pc:spChg>
+        <pc:spChg chg="mod">
+          <ac:chgData name="Afonso Duarte" userId="f1a960851f587191" providerId="LiveId" clId="{46D14D1A-50E6-400A-8836-C64EDA333A06}" dt="2025-10-22T01:03:36.820" v="64" actId="948"/>
+          <ac:spMkLst>
+            <pc:docMk/>
+            <pc:sldMk cId="3720105677" sldId="279"/>
+            <ac:spMk id="11" creationId="{27C0A113-ED86-BF3D-1B8D-55856250360A}"/>
+          </ac:spMkLst>
+        </pc:spChg>
+      </pc:sldChg>
+      <pc:sldChg chg="modSp mod">
+        <pc:chgData name="Afonso Duarte" userId="f1a960851f587191" providerId="LiveId" clId="{46D14D1A-50E6-400A-8836-C64EDA333A06}" dt="2025-10-22T00:40:52.352" v="23" actId="790"/>
+        <pc:sldMkLst>
+          <pc:docMk/>
+          <pc:sldMk cId="3559925856" sldId="280"/>
+        </pc:sldMkLst>
+        <pc:spChg chg="mod">
+          <ac:chgData name="Afonso Duarte" userId="f1a960851f587191" providerId="LiveId" clId="{46D14D1A-50E6-400A-8836-C64EDA333A06}" dt="2025-10-22T00:40:52.352" v="23" actId="790"/>
+          <ac:spMkLst>
+            <pc:docMk/>
+            <pc:sldMk cId="3559925856" sldId="280"/>
+            <ac:spMk id="2" creationId="{B68DDD29-EE51-781A-6B29-C287A028E0BC}"/>
+          </ac:spMkLst>
+        </pc:spChg>
+        <pc:spChg chg="mod">
+          <ac:chgData name="Afonso Duarte" userId="f1a960851f587191" providerId="LiveId" clId="{46D14D1A-50E6-400A-8836-C64EDA333A06}" dt="2025-10-22T00:40:52.352" v="23" actId="790"/>
+          <ac:spMkLst>
+            <pc:docMk/>
+            <pc:sldMk cId="3559925856" sldId="280"/>
+            <ac:spMk id="3" creationId="{9378FC4C-3A79-DA09-6824-B68DB21F46E2}"/>
+          </ac:spMkLst>
+        </pc:spChg>
+        <pc:spChg chg="mod">
+          <ac:chgData name="Afonso Duarte" userId="f1a960851f587191" providerId="LiveId" clId="{46D14D1A-50E6-400A-8836-C64EDA333A06}" dt="2025-10-22T00:40:52.352" v="23" actId="790"/>
+          <ac:spMkLst>
+            <pc:docMk/>
+            <pc:sldMk cId="3559925856" sldId="280"/>
+            <ac:spMk id="4" creationId="{D94CE883-457C-FF8C-EB49-31697216400C}"/>
+          </ac:spMkLst>
+        </pc:spChg>
+      </pc:sldChg>
+      <pc:sldChg chg="modSp mod">
+        <pc:chgData name="Afonso Duarte" userId="f1a960851f587191" providerId="LiveId" clId="{46D14D1A-50E6-400A-8836-C64EDA333A06}" dt="2025-10-22T00:40:52.352" v="23" actId="790"/>
+        <pc:sldMkLst>
+          <pc:docMk/>
+          <pc:sldMk cId="1464975208" sldId="281"/>
+        </pc:sldMkLst>
+        <pc:spChg chg="mod">
+          <ac:chgData name="Afonso Duarte" userId="f1a960851f587191" providerId="LiveId" clId="{46D14D1A-50E6-400A-8836-C64EDA333A06}" dt="2025-10-22T00:40:52.352" v="23" actId="790"/>
+          <ac:spMkLst>
+            <pc:docMk/>
+            <pc:sldMk cId="1464975208" sldId="281"/>
+            <ac:spMk id="2" creationId="{251AB7F7-E271-BEEA-0AF7-A91B688B2A20}"/>
+          </ac:spMkLst>
+        </pc:spChg>
+        <pc:spChg chg="mod">
+          <ac:chgData name="Afonso Duarte" userId="f1a960851f587191" providerId="LiveId" clId="{46D14D1A-50E6-400A-8836-C64EDA333A06}" dt="2025-10-22T00:40:52.352" v="23" actId="790"/>
+          <ac:spMkLst>
+            <pc:docMk/>
+            <pc:sldMk cId="1464975208" sldId="281"/>
+            <ac:spMk id="4" creationId="{7D347C2B-E6BD-2C21-D48B-76B22AD09143}"/>
+          </ac:spMkLst>
+        </pc:spChg>
+        <pc:spChg chg="mod">
+          <ac:chgData name="Afonso Duarte" userId="f1a960851f587191" providerId="LiveId" clId="{46D14D1A-50E6-400A-8836-C64EDA333A06}" dt="2025-10-22T00:40:52.352" v="23" actId="790"/>
+          <ac:spMkLst>
+            <pc:docMk/>
+            <pc:sldMk cId="1464975208" sldId="281"/>
+            <ac:spMk id="5" creationId="{11D851CA-B42D-8C15-0AEF-B0E4F6FAA6EE}"/>
+          </ac:spMkLst>
+        </pc:spChg>
+      </pc:sldChg>
+      <pc:sldChg chg="modSp mod">
+        <pc:chgData name="Afonso Duarte" userId="f1a960851f587191" providerId="LiveId" clId="{46D14D1A-50E6-400A-8836-C64EDA333A06}" dt="2025-10-22T00:40:52.352" v="23" actId="790"/>
+        <pc:sldMkLst>
+          <pc:docMk/>
+          <pc:sldMk cId="1243214271" sldId="282"/>
+        </pc:sldMkLst>
+        <pc:spChg chg="mod">
+          <ac:chgData name="Afonso Duarte" userId="f1a960851f587191" providerId="LiveId" clId="{46D14D1A-50E6-400A-8836-C64EDA333A06}" dt="2025-10-22T00:40:52.352" v="23" actId="790"/>
+          <ac:spMkLst>
+            <pc:docMk/>
+            <pc:sldMk cId="1243214271" sldId="282"/>
+            <ac:spMk id="2" creationId="{7DD75B72-3044-BBCE-7333-1287D5B5AC78}"/>
+          </ac:spMkLst>
+        </pc:spChg>
+        <pc:spChg chg="mod">
+          <ac:chgData name="Afonso Duarte" userId="f1a960851f587191" providerId="LiveId" clId="{46D14D1A-50E6-400A-8836-C64EDA333A06}" dt="2025-10-22T00:40:52.352" v="23" actId="790"/>
+          <ac:spMkLst>
+            <pc:docMk/>
+            <pc:sldMk cId="1243214271" sldId="282"/>
+            <ac:spMk id="4" creationId="{1DB8B7DB-9832-A30E-38B7-34159092AFD9}"/>
+          </ac:spMkLst>
+        </pc:spChg>
+        <pc:spChg chg="mod">
+          <ac:chgData name="Afonso Duarte" userId="f1a960851f587191" providerId="LiveId" clId="{46D14D1A-50E6-400A-8836-C64EDA333A06}" dt="2025-10-22T00:40:52.352" v="23" actId="790"/>
+          <ac:spMkLst>
+            <pc:docMk/>
+            <pc:sldMk cId="1243214271" sldId="282"/>
+            <ac:spMk id="7" creationId="{C369C5B9-2D05-7E19-BE46-87B358D9F01B}"/>
+          </ac:spMkLst>
+        </pc:spChg>
+      </pc:sldChg>
+      <pc:sldChg chg="modSp mod">
+        <pc:chgData name="Afonso Duarte" userId="f1a960851f587191" providerId="LiveId" clId="{46D14D1A-50E6-400A-8836-C64EDA333A06}" dt="2025-10-22T00:40:52.352" v="23" actId="790"/>
+        <pc:sldMkLst>
+          <pc:docMk/>
+          <pc:sldMk cId="2329296190" sldId="283"/>
+        </pc:sldMkLst>
+        <pc:spChg chg="mod">
+          <ac:chgData name="Afonso Duarte" userId="f1a960851f587191" providerId="LiveId" clId="{46D14D1A-50E6-400A-8836-C64EDA333A06}" dt="2025-10-22T00:40:52.352" v="23" actId="790"/>
+          <ac:spMkLst>
+            <pc:docMk/>
+            <pc:sldMk cId="2329296190" sldId="283"/>
+            <ac:spMk id="2" creationId="{5BEC18B9-BC81-1B88-4318-FB3238DC36DF}"/>
+          </ac:spMkLst>
+        </pc:spChg>
+        <pc:spChg chg="mod">
+          <ac:chgData name="Afonso Duarte" userId="f1a960851f587191" providerId="LiveId" clId="{46D14D1A-50E6-400A-8836-C64EDA333A06}" dt="2025-10-22T00:40:52.352" v="23" actId="790"/>
+          <ac:spMkLst>
+            <pc:docMk/>
+            <pc:sldMk cId="2329296190" sldId="283"/>
+            <ac:spMk id="3" creationId="{39B10CD7-C5DB-09D4-2668-21BF012C3AB9}"/>
+          </ac:spMkLst>
+        </pc:spChg>
+        <pc:spChg chg="mod">
+          <ac:chgData name="Afonso Duarte" userId="f1a960851f587191" providerId="LiveId" clId="{46D14D1A-50E6-400A-8836-C64EDA333A06}" dt="2025-10-22T00:40:52.352" v="23" actId="790"/>
+          <ac:spMkLst>
+            <pc:docMk/>
+            <pc:sldMk cId="2329296190" sldId="283"/>
+            <ac:spMk id="4" creationId="{EBD350AE-6C6F-4CDF-83EE-D70B1AA5ACDE}"/>
+          </ac:spMkLst>
+        </pc:spChg>
+      </pc:sldChg>
+      <pc:sldChg chg="modSp mod">
+        <pc:chgData name="Afonso Duarte" userId="f1a960851f587191" providerId="LiveId" clId="{46D14D1A-50E6-400A-8836-C64EDA333A06}" dt="2025-10-22T01:05:56.120" v="73" actId="1076"/>
+        <pc:sldMkLst>
+          <pc:docMk/>
+          <pc:sldMk cId="1272143447" sldId="284"/>
+        </pc:sldMkLst>
+        <pc:spChg chg="mod">
+          <ac:chgData name="Afonso Duarte" userId="f1a960851f587191" providerId="LiveId" clId="{46D14D1A-50E6-400A-8836-C64EDA333A06}" dt="2025-10-22T01:05:47.145" v="70" actId="1076"/>
+          <ac:spMkLst>
+            <pc:docMk/>
+            <pc:sldMk cId="1272143447" sldId="284"/>
+            <ac:spMk id="2" creationId="{18DF083F-21EB-1001-A4A8-F4529A4E2D52}"/>
+          </ac:spMkLst>
+        </pc:spChg>
+        <pc:spChg chg="mod">
+          <ac:chgData name="Afonso Duarte" userId="f1a960851f587191" providerId="LiveId" clId="{46D14D1A-50E6-400A-8836-C64EDA333A06}" dt="2025-10-22T01:05:51.164" v="71" actId="1076"/>
+          <ac:spMkLst>
+            <pc:docMk/>
+            <pc:sldMk cId="1272143447" sldId="284"/>
+            <ac:spMk id="9" creationId="{118D0560-E06A-5BE5-036B-30F3AD6D1640}"/>
+          </ac:spMkLst>
+        </pc:spChg>
+        <pc:picChg chg="mod">
+          <ac:chgData name="Afonso Duarte" userId="f1a960851f587191" providerId="LiveId" clId="{46D14D1A-50E6-400A-8836-C64EDA333A06}" dt="2025-10-22T01:05:56.120" v="73" actId="1076"/>
+          <ac:picMkLst>
+            <pc:docMk/>
+            <pc:sldMk cId="1272143447" sldId="284"/>
+            <ac:picMk id="7" creationId="{858D7349-82A6-C7F8-509E-64B413C68153}"/>
+          </ac:picMkLst>
+        </pc:picChg>
+      </pc:sldChg>
+    </pc:docChg>
+  </pc:docChgLst>
+</pc:chgInfo>
 </file>
 
 <file path=ppt/slideLayouts/slideLayout1.xml><?xml version="1.0" encoding="utf-8"?>
@@ -269,7 +843,7 @@
           <a:p>
             <a:fld id="{D329EECC-0A17-4859-8020-02B7AD02251B}" type="datetimeFigureOut">
               <a:rPr lang="pt-PT" smtClean="0"/>
-              <a:t>21/10/2025</a:t>
+              <a:t>22/10/2025</a:t>
             </a:fld>
             <a:endParaRPr lang="pt-PT"/>
           </a:p>
@@ -469,7 +1043,7 @@
           <a:p>
             <a:fld id="{D329EECC-0A17-4859-8020-02B7AD02251B}" type="datetimeFigureOut">
               <a:rPr lang="pt-PT" smtClean="0"/>
-              <a:t>21/10/2025</a:t>
+              <a:t>22/10/2025</a:t>
             </a:fld>
             <a:endParaRPr lang="pt-PT"/>
           </a:p>
@@ -679,7 +1253,7 @@
           <a:p>
             <a:fld id="{D329EECC-0A17-4859-8020-02B7AD02251B}" type="datetimeFigureOut">
               <a:rPr lang="pt-PT" smtClean="0"/>
-              <a:t>21/10/2025</a:t>
+              <a:t>22/10/2025</a:t>
             </a:fld>
             <a:endParaRPr lang="pt-PT"/>
           </a:p>
@@ -933,7 +1507,7 @@
           <a:p>
             <a:fld id="{D329EECC-0A17-4859-8020-02B7AD02251B}" type="datetimeFigureOut">
               <a:rPr lang="pt-PT" smtClean="0"/>
-              <a:t>21/10/2025</a:t>
+              <a:t>22/10/2025</a:t>
             </a:fld>
             <a:endParaRPr lang="pt-PT"/>
           </a:p>
@@ -1209,7 +1783,7 @@
           <a:p>
             <a:fld id="{D329EECC-0A17-4859-8020-02B7AD02251B}" type="datetimeFigureOut">
               <a:rPr lang="pt-PT" smtClean="0"/>
-              <a:t>21/10/2025</a:t>
+              <a:t>22/10/2025</a:t>
             </a:fld>
             <a:endParaRPr lang="pt-PT"/>
           </a:p>
@@ -1477,7 +2051,7 @@
           <a:p>
             <a:fld id="{D329EECC-0A17-4859-8020-02B7AD02251B}" type="datetimeFigureOut">
               <a:rPr lang="pt-PT" smtClean="0"/>
-              <a:t>21/10/2025</a:t>
+              <a:t>22/10/2025</a:t>
             </a:fld>
             <a:endParaRPr lang="pt-PT"/>
           </a:p>
@@ -1892,7 +2466,7 @@
           <a:p>
             <a:fld id="{D329EECC-0A17-4859-8020-02B7AD02251B}" type="datetimeFigureOut">
               <a:rPr lang="pt-PT" smtClean="0"/>
-              <a:t>21/10/2025</a:t>
+              <a:t>22/10/2025</a:t>
             </a:fld>
             <a:endParaRPr lang="pt-PT"/>
           </a:p>
@@ -2034,7 +2608,7 @@
           <a:p>
             <a:fld id="{D329EECC-0A17-4859-8020-02B7AD02251B}" type="datetimeFigureOut">
               <a:rPr lang="pt-PT" smtClean="0"/>
-              <a:t>21/10/2025</a:t>
+              <a:t>22/10/2025</a:t>
             </a:fld>
             <a:endParaRPr lang="pt-PT"/>
           </a:p>
@@ -2147,7 +2721,7 @@
           <a:p>
             <a:fld id="{D329EECC-0A17-4859-8020-02B7AD02251B}" type="datetimeFigureOut">
               <a:rPr lang="pt-PT" smtClean="0"/>
-              <a:t>21/10/2025</a:t>
+              <a:t>22/10/2025</a:t>
             </a:fld>
             <a:endParaRPr lang="pt-PT"/>
           </a:p>
@@ -2460,7 +3034,7 @@
           <a:p>
             <a:fld id="{D329EECC-0A17-4859-8020-02B7AD02251B}" type="datetimeFigureOut">
               <a:rPr lang="pt-PT" smtClean="0"/>
-              <a:t>21/10/2025</a:t>
+              <a:t>22/10/2025</a:t>
             </a:fld>
             <a:endParaRPr lang="pt-PT"/>
           </a:p>
@@ -2749,7 +3323,7 @@
           <a:p>
             <a:fld id="{D329EECC-0A17-4859-8020-02B7AD02251B}" type="datetimeFigureOut">
               <a:rPr lang="pt-PT" smtClean="0"/>
-              <a:t>21/10/2025</a:t>
+              <a:t>22/10/2025</a:t>
             </a:fld>
             <a:endParaRPr lang="pt-PT"/>
           </a:p>
@@ -2992,7 +3566,7 @@
           <a:p>
             <a:fld id="{D329EECC-0A17-4859-8020-02B7AD02251B}" type="datetimeFigureOut">
               <a:rPr lang="pt-PT" smtClean="0"/>
-              <a:t>21/10/2025</a:t>
+              <a:t>22/10/2025</a:t>
             </a:fld>
             <a:endParaRPr lang="pt-PT"/>
           </a:p>
@@ -3528,8 +4102,8 @@
         </p:nvSpPr>
         <p:spPr bwMode="auto">
           <a:xfrm>
-            <a:off x="836612" y="1765875"/>
-            <a:ext cx="5617198" cy="4154984"/>
+            <a:off x="836612" y="1611987"/>
+            <a:ext cx="5617198" cy="4462760"/>
           </a:xfrm>
           <a:prstGeom prst="rect">
             <a:avLst/>
@@ -3582,7 +4156,7 @@
                 <a:spcPct val="100000"/>
               </a:lnSpc>
               <a:spcBef>
-                <a:spcPct val="0"/>
+                <a:spcPts val="1200"/>
               </a:spcBef>
               <a:spcAft>
                 <a:spcPct val="0"/>
@@ -3604,7 +4178,7 @@
                 <a:spcPct val="100000"/>
               </a:lnSpc>
               <a:spcBef>
-                <a:spcPct val="0"/>
+                <a:spcPts val="1200"/>
               </a:spcBef>
               <a:spcAft>
                 <a:spcPct val="0"/>
@@ -3623,7 +4197,7 @@
           <a:p>
             <a:pPr lvl="0" eaLnBrk="0" fontAlgn="base" hangingPunct="0">
               <a:spcBef>
-                <a:spcPct val="0"/>
+                <a:spcPts val="1200"/>
               </a:spcBef>
               <a:spcAft>
                 <a:spcPct val="0"/>
@@ -3903,8 +4477,8 @@
         </p:nvSpPr>
         <p:spPr bwMode="auto">
           <a:xfrm>
-            <a:off x="836612" y="2133386"/>
-            <a:ext cx="5849111" cy="3416320"/>
+            <a:off x="836612" y="2056442"/>
+            <a:ext cx="5849111" cy="3570208"/>
           </a:xfrm>
           <a:prstGeom prst="rect">
             <a:avLst/>
@@ -3957,7 +4531,7 @@
                 <a:spcPct val="100000"/>
               </a:lnSpc>
               <a:spcBef>
-                <a:spcPct val="0"/>
+                <a:spcPts val="1200"/>
               </a:spcBef>
               <a:spcAft>
                 <a:spcPct val="0"/>
@@ -3979,7 +4553,7 @@
                 <a:spcPct val="100000"/>
               </a:lnSpc>
               <a:spcBef>
-                <a:spcPct val="0"/>
+                <a:spcPts val="1200"/>
               </a:spcBef>
               <a:spcAft>
                 <a:spcPct val="0"/>
@@ -4079,11 +4653,11 @@
   <p:clrMapOvr>
     <a:masterClrMapping/>
   </p:clrMapOvr>
-  <mc:AlternateContent xmlns:mc="http://schemas.openxmlformats.org/markup-compatibility/2006">
-    <mc:Choice xmlns:p14="http://schemas.microsoft.com/office/powerpoint/2010/main" Requires="p14">
+  <mc:AlternateContent xmlns:mc="http://schemas.openxmlformats.org/markup-compatibility/2006" xmlns:p14="http://schemas.microsoft.com/office/powerpoint/2010/main">
+    <mc:Choice Requires="p14">
       <p:transition p14:dur="10"/>
     </mc:Choice>
-    <mc:Fallback>
+    <mc:Fallback xmlns="">
       <p:transition/>
     </mc:Fallback>
   </mc:AlternateContent>
@@ -4354,7 +4928,7 @@
                 <a:spcPct val="100000"/>
               </a:lnSpc>
               <a:spcBef>
-                <a:spcPct val="0"/>
+                <a:spcPts val="1200"/>
               </a:spcBef>
               <a:spcAft>
                 <a:spcPct val="0"/>
@@ -4498,8 +5072,8 @@
         </p:nvSpPr>
         <p:spPr bwMode="auto">
           <a:xfrm>
-            <a:off x="701475" y="2728022"/>
-            <a:ext cx="6578220" cy="1938992"/>
+            <a:off x="701475" y="2651078"/>
+            <a:ext cx="6578220" cy="2092881"/>
           </a:xfrm>
           <a:prstGeom prst="rect">
             <a:avLst/>
@@ -4552,7 +5126,7 @@
                 <a:spcPct val="100000"/>
               </a:lnSpc>
               <a:spcBef>
-                <a:spcPct val="0"/>
+                <a:spcPts val="1200"/>
               </a:spcBef>
               <a:spcAft>
                 <a:spcPct val="0"/>
@@ -4574,7 +5148,7 @@
                 <a:spcPct val="100000"/>
               </a:lnSpc>
               <a:spcBef>
-                <a:spcPct val="0"/>
+                <a:spcPts val="1200"/>
               </a:spcBef>
               <a:spcAft>
                 <a:spcPct val="0"/>
@@ -4793,7 +5367,7 @@
         </p:nvSpPr>
         <p:spPr>
           <a:xfrm>
-            <a:off x="1115568" y="548640"/>
+            <a:off x="1115568" y="182716"/>
             <a:ext cx="10168128" cy="1179576"/>
           </a:xfrm>
         </p:spPr>
@@ -4832,7 +5406,7 @@
         </p:blipFill>
         <p:spPr>
           <a:xfrm>
-            <a:off x="4574794" y="5129785"/>
+            <a:off x="4176444" y="5081308"/>
             <a:ext cx="3839111" cy="1600423"/>
           </a:xfrm>
           <a:prstGeom prst="rect">
@@ -4856,8 +5430,8 @@
         </p:nvSpPr>
         <p:spPr bwMode="auto">
           <a:xfrm>
-            <a:off x="1115568" y="1344133"/>
-            <a:ext cx="10757564" cy="3785652"/>
+            <a:off x="1115568" y="984836"/>
+            <a:ext cx="10757564" cy="4093428"/>
           </a:xfrm>
           <a:prstGeom prst="rect">
             <a:avLst/>
@@ -4910,7 +5484,7 @@
                 <a:spcPct val="100000"/>
               </a:lnSpc>
               <a:spcBef>
-                <a:spcPct val="0"/>
+                <a:spcPts val="1200"/>
               </a:spcBef>
               <a:spcAft>
                 <a:spcPct val="0"/>
@@ -4932,7 +5506,7 @@
                 <a:spcPct val="100000"/>
               </a:lnSpc>
               <a:spcBef>
-                <a:spcPct val="0"/>
+                <a:spcPts val="1200"/>
               </a:spcBef>
               <a:spcAft>
                 <a:spcPct val="0"/>
@@ -4954,7 +5528,7 @@
                 <a:spcPct val="100000"/>
               </a:lnSpc>
               <a:spcBef>
-                <a:spcPct val="0"/>
+                <a:spcPts val="1200"/>
               </a:spcBef>
               <a:spcAft>
                 <a:spcPct val="0"/>
@@ -5853,84 +6427,131 @@
       </p:sp>
       <p:sp>
         <p:nvSpPr>
-          <p:cNvPr id="3" name="Content Placeholder 2">
-            <a:extLst>
-              <a:ext uri="{FF2B5EF4-FFF2-40B4-BE49-F238E27FC236}">
-                <a16:creationId xmlns:a16="http://schemas.microsoft.com/office/drawing/2014/main" id="{367486E0-D9DD-4D28-00B3-822B9182BF98}"/>
-              </a:ext>
-            </a:extLst>
-          </p:cNvPr>
-          <p:cNvSpPr>
-            <a:spLocks noGrp="1"/>
-          </p:cNvSpPr>
-          <p:nvPr>
-            <p:ph idx="1"/>
-          </p:nvPr>
-        </p:nvSpPr>
-        <p:spPr>
+          <p:cNvPr id="4" name="Rectangle 1">
+            <a:extLst>
+              <a:ext uri="{FF2B5EF4-FFF2-40B4-BE49-F238E27FC236}">
+                <a16:creationId xmlns:a16="http://schemas.microsoft.com/office/drawing/2014/main" id="{6AB95D55-7CA9-D1F0-4654-17A4E24B2008}"/>
+              </a:ext>
+            </a:extLst>
+          </p:cNvPr>
+          <p:cNvSpPr>
+            <a:spLocks noChangeArrowheads="1"/>
+          </p:cNvSpPr>
+          <p:nvPr/>
+        </p:nvSpPr>
+        <p:spPr bwMode="auto">
           <a:xfrm>
-            <a:off x="1115568" y="2481943"/>
-            <a:ext cx="10168128" cy="3695020"/>
-          </a:xfrm>
-        </p:spPr>
-        <p:txBody>
-          <a:bodyPr>
-            <a:normAutofit/>
+            <a:off x="1115568" y="2315381"/>
+            <a:ext cx="10607040" cy="3886257"/>
+          </a:xfrm>
+          <a:prstGeom prst="rect">
+            <a:avLst/>
+          </a:prstGeom>
+          <a:noFill/>
+          <a:ln>
+            <a:noFill/>
+          </a:ln>
+          <a:effectLst/>
+          <a:extLst>
+            <a:ext uri="{909E8E84-426E-40DD-AFC4-6F175D3DCCD1}">
+              <a14:hiddenFill xmlns:a14="http://schemas.microsoft.com/office/drawing/2010/main">
+                <a:solidFill>
+                  <a:schemeClr val="accent1"/>
+                </a:solidFill>
+              </a14:hiddenFill>
+            </a:ext>
+            <a:ext uri="{91240B29-F687-4F45-9708-019B960494DF}">
+              <a14:hiddenLine xmlns:a14="http://schemas.microsoft.com/office/drawing/2010/main" w="9525">
+                <a:solidFill>
+                  <a:schemeClr val="tx1"/>
+                </a:solidFill>
+                <a:miter lim="800000"/>
+                <a:headEnd/>
+                <a:tailEnd/>
+              </a14:hiddenLine>
+            </a:ext>
+            <a:ext uri="{AF507438-7753-43E0-B8FC-AC1667EBCBE1}">
+              <a14:hiddenEffects xmlns:a14="http://schemas.microsoft.com/office/drawing/2010/main">
+                <a:effectLst>
+                  <a:outerShdw dist="35921" dir="2700000" algn="ctr" rotWithShape="0">
+                    <a:schemeClr val="bg2"/>
+                  </a:outerShdw>
+                </a:effectLst>
+              </a14:hiddenEffects>
+            </a:ext>
+          </a:extLst>
+        </p:spPr>
+        <p:txBody>
+          <a:bodyPr vert="horz" wrap="square" lIns="91440" tIns="45720" rIns="91440" bIns="45720" numCol="1" anchor="ctr" anchorCtr="0" compatLnSpc="1">
+            <a:prstTxWarp prst="textNoShape">
+              <a:avLst/>
+            </a:prstTxWarp>
+            <a:spAutoFit/>
           </a:bodyPr>
           <a:lstStyle/>
           <a:p>
+            <a:pPr marL="342900" marR="0" lvl="0" indent="-342900" algn="l" defTabSz="914400" rtl="0" eaLnBrk="0" fontAlgn="base" latinLnBrk="0" hangingPunct="0">
+              <a:spcBef>
+                <a:spcPts val="600"/>
+              </a:spcBef>
+              <a:buClrTx/>
+              <a:buSzTx/>
+              <a:buFont typeface="Arial" panose="020B0604020202020204" pitchFamily="34" charset="0"/>
+              <a:buChar char="•"/>
+              <a:tabLst/>
+            </a:pPr>
             <a:r>
               <a:rPr lang="en-US" sz="2400" noProof="0" dirty="0"/>
-              <a:t>Industrial expansion has significantly altered the composition of the atmosphere.</a:t>
-            </a:r>
-          </a:p>
-          <a:p>
+              <a:t> Rapid urbanization and industrial growth have significantly altered atmospheric composition, leading to increased air pollution.</a:t>
+            </a:r>
+          </a:p>
+          <a:p>
+            <a:pPr marL="342900" marR="0" lvl="0" indent="-342900" algn="l" defTabSz="914400" rtl="0" eaLnBrk="0" fontAlgn="base" latinLnBrk="0" hangingPunct="0">
+              <a:spcBef>
+                <a:spcPts val="1200"/>
+              </a:spcBef>
+              <a:buClrTx/>
+              <a:buSzTx/>
+              <a:buFont typeface="Arial" panose="020B0604020202020204" pitchFamily="34" charset="0"/>
+              <a:buChar char="•"/>
+              <a:tabLst/>
+            </a:pPr>
             <a:r>
               <a:rPr lang="en-US" sz="2400" noProof="0" dirty="0"/>
-              <a:t>Accurately quantifying these changes is essential for environmental monitoring and policy-making.</a:t>
-            </a:r>
-          </a:p>
-          <a:p>
-            <a:r>
-              <a:rPr lang="en-US" sz="2400" b="1" noProof="0" dirty="0"/>
-              <a:t>Fuzzy</a:t>
-            </a:r>
+              <a:t> Accurate air quality forecasting is essential for effective environmental monitoring and public health protection.</a:t>
+            </a:r>
+          </a:p>
+          <a:p>
+            <a:pPr marL="342900" marR="0" lvl="0" indent="-342900" algn="l" defTabSz="914400" rtl="0" eaLnBrk="0" fontAlgn="base" latinLnBrk="0" hangingPunct="0">
+              <a:lnSpc>
+                <a:spcPct val="150000"/>
+              </a:lnSpc>
+              <a:buClrTx/>
+              <a:buSzTx/>
+              <a:buFont typeface="Arial" panose="020B0604020202020204" pitchFamily="34" charset="0"/>
+              <a:buChar char="•"/>
+              <a:tabLst/>
+            </a:pPr>
             <a:r>
               <a:rPr lang="en-US" sz="2400" noProof="0" dirty="0"/>
-              <a:t> and </a:t>
-            </a:r>
-            <a:r>
-              <a:rPr lang="en-US" sz="2400" b="1" noProof="0" dirty="0"/>
-              <a:t>Neuro-Fuzzy</a:t>
-            </a:r>
+              <a:t>Fuzzy and Neuro-Fuzzy models offer robust tools to handle uncertainty and nonlinear relationships in environmental data.</a:t>
+            </a:r>
+          </a:p>
+          <a:p>
+            <a:pPr marL="342900" marR="0" lvl="0" indent="-342900" algn="l" defTabSz="914400" rtl="0" eaLnBrk="0" fontAlgn="base" latinLnBrk="0" hangingPunct="0">
+              <a:lnSpc>
+                <a:spcPct val="150000"/>
+              </a:lnSpc>
+              <a:buClrTx/>
+              <a:buSzTx/>
+              <a:buFont typeface="Arial" panose="020B0604020202020204" pitchFamily="34" charset="0"/>
+              <a:buChar char="•"/>
+              <a:tabLst/>
+            </a:pPr>
             <a:r>
               <a:rPr lang="en-US" sz="2400" noProof="0" dirty="0"/>
-              <a:t> models are effective tools for modeling such complex, uncertain systems.</a:t>
-            </a:r>
-          </a:p>
-          <a:p>
-            <a:r>
-              <a:rPr lang="en-US" sz="2400" b="1" noProof="0" dirty="0"/>
-              <a:t>Main Objective:</a:t>
-            </a:r>
-            <a:r>
-              <a:rPr lang="en-US" sz="2400" noProof="0" dirty="0"/>
-              <a:t> Compare the performance of different fuzzy models against a </a:t>
-            </a:r>
-            <a:r>
-              <a:rPr lang="en-US" sz="2400" b="1" noProof="0" dirty="0"/>
-              <a:t>Deep Learning</a:t>
-            </a:r>
-            <a:r>
-              <a:rPr lang="en-US" sz="2400" noProof="0" dirty="0"/>
-              <a:t> approach.</a:t>
-            </a:r>
-          </a:p>
-          <a:p>
-            <a:pPr marL="0" indent="0">
-              <a:buNone/>
-            </a:pPr>
-            <a:endParaRPr lang="en-US" sz="2400" noProof="0" dirty="0"/>
+              <a:t> Main Objective: Compare the performance of Fuzzy, Neuro-Fuzzy, and Deep Learning (LSTM) models for air quality prediction.</a:t>
+            </a:r>
           </a:p>
         </p:txBody>
       </p:sp>
@@ -6504,12 +7125,42 @@
           </a:bodyPr>
           <a:lstStyle/>
           <a:p>
+            <a:pPr>
+              <a:lnSpc>
+                <a:spcPct val="100000"/>
+              </a:lnSpc>
+              <a:spcBef>
+                <a:spcPts val="1200"/>
+              </a:spcBef>
+            </a:pPr>
+            <a:r>
+              <a:rPr lang="en-US" sz="2400" dirty="0"/>
+              <a:t>Air Quality dataset from the UCI Machine Learning Repository</a:t>
+            </a:r>
+          </a:p>
+          <a:p>
+            <a:pPr>
+              <a:lnSpc>
+                <a:spcPct val="100000"/>
+              </a:lnSpc>
+              <a:spcBef>
+                <a:spcPts val="1200"/>
+              </a:spcBef>
+            </a:pPr>
             <a:r>
               <a:rPr lang="en-US" sz="2400" noProof="0" dirty="0"/>
               <a:t>Contains 9,358 hourly measurements collected between March 2004 and February 2005;</a:t>
             </a:r>
           </a:p>
           <a:p>
+            <a:pPr>
+              <a:lnSpc>
+                <a:spcPct val="100000"/>
+              </a:lnSpc>
+              <a:spcBef>
+                <a:spcPts val="1200"/>
+              </a:spcBef>
+            </a:pPr>
             <a:r>
               <a:rPr lang="en-US" sz="2400" noProof="0" dirty="0"/>
               <a:t>The original dataset includes 15 numerical attributes: </a:t>
@@ -6517,6 +7168,12 @@
           </a:p>
           <a:p>
             <a:pPr marL="0" indent="0">
+              <a:lnSpc>
+                <a:spcPct val="100000"/>
+              </a:lnSpc>
+              <a:spcBef>
+                <a:spcPts val="1200"/>
+              </a:spcBef>
               <a:buNone/>
             </a:pPr>
             <a:r>
@@ -7007,8 +7664,8 @@
         </p:blipFill>
         <p:spPr>
           <a:xfrm>
-            <a:off x="5646683" y="712908"/>
-            <a:ext cx="5443870" cy="2939690"/>
+            <a:off x="5612748" y="565679"/>
+            <a:ext cx="5747107" cy="3103438"/>
           </a:xfrm>
           <a:prstGeom prst="rect">
             <a:avLst/>
@@ -7043,8 +7700,8 @@
         </p:blipFill>
         <p:spPr>
           <a:xfrm>
-            <a:off x="5251416" y="3959931"/>
-            <a:ext cx="5965746" cy="2416126"/>
+            <a:off x="5251416" y="3829221"/>
+            <a:ext cx="6477050" cy="2623204"/>
           </a:xfrm>
           <a:prstGeom prst="rect">
             <a:avLst/>
@@ -7565,7 +8222,13 @@
   <p:cSld>
     <p:spTree>
       <p:nvGrpSpPr>
-        <p:cNvPr id="1" name=""/>
+        <p:cNvPr id="1" name="">
+          <a:extLst>
+            <a:ext uri="{FF2B5EF4-FFF2-40B4-BE49-F238E27FC236}">
+              <a16:creationId xmlns:a16="http://schemas.microsoft.com/office/drawing/2014/main" id="{52C43C46-FF76-74FC-217D-19BF78337CBC}"/>
+            </a:ext>
+          </a:extLst>
+        </p:cNvPr>
         <p:cNvGrpSpPr/>
         <p:nvPr/>
       </p:nvGrpSpPr>
@@ -7582,7 +8245,7 @@
           <p:cNvPr id="2" name="Title 1">
             <a:extLst>
               <a:ext uri="{FF2B5EF4-FFF2-40B4-BE49-F238E27FC236}">
-                <a16:creationId xmlns:a16="http://schemas.microsoft.com/office/drawing/2014/main" id="{9D751291-12F3-6270-C31E-1818E8DD6EB3}"/>
+                <a16:creationId xmlns:a16="http://schemas.microsoft.com/office/drawing/2014/main" id="{05ED50FA-A298-9FE7-D884-3E2642F8AFA9}"/>
               </a:ext>
             </a:extLst>
           </p:cNvPr>
@@ -7615,7 +8278,7 @@
           <p:cNvPr id="4" name="Text Placeholder 3">
             <a:extLst>
               <a:ext uri="{FF2B5EF4-FFF2-40B4-BE49-F238E27FC236}">
-                <a16:creationId xmlns:a16="http://schemas.microsoft.com/office/drawing/2014/main" id="{539F5613-7FF4-F7F6-7C43-CF0FA77249D3}"/>
+                <a16:creationId xmlns:a16="http://schemas.microsoft.com/office/drawing/2014/main" id="{41567421-318E-11BE-B85E-09AC56258A33}"/>
               </a:ext>
             </a:extLst>
           </p:cNvPr>
@@ -7638,7 +8301,7 @@
           <a:p>
             <a:r>
               <a:rPr lang="en-US" noProof="0" dirty="0"/>
-              <a:t>Fuzzy Model Optimized with Least Squares</a:t>
+              <a:t>ANFIS model</a:t>
             </a:r>
           </a:p>
         </p:txBody>
@@ -7648,7 +8311,7 @@
           <p:cNvPr id="11" name="Rectangle 3">
             <a:extLst>
               <a:ext uri="{FF2B5EF4-FFF2-40B4-BE49-F238E27FC236}">
-                <a16:creationId xmlns:a16="http://schemas.microsoft.com/office/drawing/2014/main" id="{ABA8A5C0-E552-7235-000A-E2311CB3CCE0}"/>
+                <a16:creationId xmlns:a16="http://schemas.microsoft.com/office/drawing/2014/main" id="{27C0A113-ED86-BF3D-1B8D-55856250360A}"/>
               </a:ext>
             </a:extLst>
           </p:cNvPr>
@@ -7659,8 +8322,8 @@
         </p:nvSpPr>
         <p:spPr bwMode="auto">
           <a:xfrm>
-            <a:off x="836612" y="2354467"/>
-            <a:ext cx="5374274" cy="3046988"/>
+            <a:off x="836612" y="2452536"/>
+            <a:ext cx="4928083" cy="2677656"/>
           </a:xfrm>
           <a:prstGeom prst="rect">
             <a:avLst/>
@@ -7708,69 +8371,31 @@
           </a:bodyPr>
           <a:lstStyle/>
           <a:p>
-            <a:pPr marL="0" marR="0" lvl="0" indent="0" algn="l" defTabSz="914400" rtl="0" eaLnBrk="0" fontAlgn="base" latinLnBrk="0" hangingPunct="0">
-              <a:lnSpc>
-                <a:spcPct val="100000"/>
-              </a:lnSpc>
+            <a:pPr lvl="0" eaLnBrk="0" fontAlgn="base" hangingPunct="0">
               <a:spcBef>
-                <a:spcPct val="0"/>
+                <a:spcPts val="1200"/>
               </a:spcBef>
               <a:spcAft>
                 <a:spcPct val="0"/>
               </a:spcAft>
-              <a:buClrTx/>
-              <a:buSzTx/>
               <a:buFontTx/>
               <a:buChar char="•"/>
-              <a:tabLst/>
             </a:pPr>
             <a:r>
+              <a:rPr lang="en-US" sz="2400" b="1" noProof="0" dirty="0"/>
+              <a:t> ANFIS Architecture:</a:t>
+            </a:r>
+            <a:r>
               <a:rPr lang="en-US" sz="2400" noProof="0" dirty="0"/>
-              <a:t>TSK model baseline chosen for its interpretability and robustness to noisy data.</a:t>
-            </a:r>
-          </a:p>
-          <a:p>
-            <a:pPr marL="0" marR="0" lvl="0" indent="0" algn="l" defTabSz="914400" rtl="0" eaLnBrk="0" fontAlgn="base" latinLnBrk="0" hangingPunct="0">
-              <a:lnSpc>
-                <a:spcPct val="100000"/>
-              </a:lnSpc>
-              <a:spcBef>
-                <a:spcPct val="0"/>
-              </a:spcBef>
-              <a:spcAft>
-                <a:spcPct val="0"/>
-              </a:spcAft>
-              <a:buClrTx/>
-              <a:buSzTx/>
-              <a:buFontTx/>
-              <a:buChar char="•"/>
-              <a:tabLst/>
-            </a:pPr>
+              <a:t> First-order Takagi–</a:t>
+            </a:r>
+            <a:r>
+              <a:rPr lang="en-US" sz="2400" noProof="0" dirty="0" err="1"/>
+              <a:t>Sugeno</a:t>
+            </a:r>
             <a:r>
               <a:rPr lang="en-US" sz="2400" noProof="0" dirty="0"/>
-              <a:t>Fuzzy rules generated via Fuzzy C-Means and Gaussian MFs initialized and rule outputs trained using Least Squares regression.</a:t>
-            </a:r>
-          </a:p>
-          <a:p>
-            <a:pPr marL="0" marR="0" lvl="0" indent="0" algn="l" defTabSz="914400" rtl="0" eaLnBrk="0" fontAlgn="base" latinLnBrk="0" hangingPunct="0">
-              <a:lnSpc>
-                <a:spcPct val="100000"/>
-              </a:lnSpc>
-              <a:spcBef>
-                <a:spcPct val="0"/>
-              </a:spcBef>
-              <a:spcAft>
-                <a:spcPct val="0"/>
-              </a:spcAft>
-              <a:buClrTx/>
-              <a:buSzTx/>
-              <a:buFontTx/>
-              <a:buChar char="•"/>
-              <a:tabLst/>
-            </a:pPr>
-            <a:r>
-              <a:rPr lang="en-US" sz="2400" noProof="0" dirty="0"/>
-              <a:t>RMSE = 0.2196; </a:t>
+              <a:t>–Kang (TSK) structure with five Gaussian membership functions per input, combining fuzzy rules with linear consequents to model nonlinear relationships while maintaining interpretability.</a:t>
             </a:r>
             <a:endParaRPr kumimoji="0" lang="en-US" sz="1800" b="0" i="0" u="none" strike="noStrike" cap="none" normalizeH="0" baseline="0" noProof="0" dirty="0">
               <a:ln>
@@ -7787,10 +8412,10 @@
       </p:sp>
       <p:pic>
         <p:nvPicPr>
-          <p:cNvPr id="13" name="Picture 12" descr="A graph with a line drawn on it&#10;&#10;AI-generated content may be incorrect.">
-            <a:extLst>
-              <a:ext uri="{FF2B5EF4-FFF2-40B4-BE49-F238E27FC236}">
-                <a16:creationId xmlns:a16="http://schemas.microsoft.com/office/drawing/2014/main" id="{8A7E7967-342C-BCCB-22A9-BBE00F9C3FF4}"/>
+          <p:cNvPr id="6" name="Picture 5" descr="A diagram of a machine learning&#10;&#10;AI-generated content may be incorrect.">
+            <a:extLst>
+              <a:ext uri="{FF2B5EF4-FFF2-40B4-BE49-F238E27FC236}">
+                <a16:creationId xmlns:a16="http://schemas.microsoft.com/office/drawing/2014/main" id="{61F93F47-AE8A-62F7-F839-88066D0965F5}"/>
               </a:ext>
             </a:extLst>
           </p:cNvPr>
@@ -7813,8 +8438,8 @@
         </p:blipFill>
         <p:spPr>
           <a:xfrm>
-            <a:off x="6557889" y="1579389"/>
-            <a:ext cx="5114021" cy="4973083"/>
+            <a:off x="6404679" y="1140204"/>
+            <a:ext cx="4945401" cy="5352670"/>
           </a:xfrm>
           <a:prstGeom prst="rect">
             <a:avLst/>
@@ -7824,7 +8449,7 @@
     </p:spTree>
     <p:extLst>
       <p:ext uri="{BB962C8B-B14F-4D97-AF65-F5344CB8AC3E}">
-        <p14:creationId xmlns:p14="http://schemas.microsoft.com/office/powerpoint/2010/main" val="3403054834"/>
+        <p14:creationId xmlns:p14="http://schemas.microsoft.com/office/powerpoint/2010/main" val="3720105677"/>
       </p:ext>
     </p:extLst>
   </p:cSld>
@@ -7839,13 +8464,7 @@
   <p:cSld>
     <p:spTree>
       <p:nvGrpSpPr>
-        <p:cNvPr id="1" name="">
-          <a:extLst>
-            <a:ext uri="{FF2B5EF4-FFF2-40B4-BE49-F238E27FC236}">
-              <a16:creationId xmlns:a16="http://schemas.microsoft.com/office/drawing/2014/main" id="{52C43C46-FF76-74FC-217D-19BF78337CBC}"/>
-            </a:ext>
-          </a:extLst>
-        </p:cNvPr>
+        <p:cNvPr id="1" name=""/>
         <p:cNvGrpSpPr/>
         <p:nvPr/>
       </p:nvGrpSpPr>
@@ -7862,7 +8481,7 @@
           <p:cNvPr id="2" name="Title 1">
             <a:extLst>
               <a:ext uri="{FF2B5EF4-FFF2-40B4-BE49-F238E27FC236}">
-                <a16:creationId xmlns:a16="http://schemas.microsoft.com/office/drawing/2014/main" id="{05ED50FA-A298-9FE7-D884-3E2642F8AFA9}"/>
+                <a16:creationId xmlns:a16="http://schemas.microsoft.com/office/drawing/2014/main" id="{9D751291-12F3-6270-C31E-1818E8DD6EB3}"/>
               </a:ext>
             </a:extLst>
           </p:cNvPr>
@@ -7895,7 +8514,7 @@
           <p:cNvPr id="4" name="Text Placeholder 3">
             <a:extLst>
               <a:ext uri="{FF2B5EF4-FFF2-40B4-BE49-F238E27FC236}">
-                <a16:creationId xmlns:a16="http://schemas.microsoft.com/office/drawing/2014/main" id="{41567421-318E-11BE-B85E-09AC56258A33}"/>
+                <a16:creationId xmlns:a16="http://schemas.microsoft.com/office/drawing/2014/main" id="{539F5613-7FF4-F7F6-7C43-CF0FA77249D3}"/>
               </a:ext>
             </a:extLst>
           </p:cNvPr>
@@ -7918,7 +8537,7 @@
           <a:p>
             <a:r>
               <a:rPr lang="en-US" noProof="0" dirty="0"/>
-              <a:t>ANFIS model</a:t>
+              <a:t>Fuzzy Model Optimized with Least Squares</a:t>
             </a:r>
           </a:p>
         </p:txBody>
@@ -7928,7 +8547,7 @@
           <p:cNvPr id="11" name="Rectangle 3">
             <a:extLst>
               <a:ext uri="{FF2B5EF4-FFF2-40B4-BE49-F238E27FC236}">
-                <a16:creationId xmlns:a16="http://schemas.microsoft.com/office/drawing/2014/main" id="{27C0A113-ED86-BF3D-1B8D-55856250360A}"/>
+                <a16:creationId xmlns:a16="http://schemas.microsoft.com/office/drawing/2014/main" id="{ABA8A5C0-E552-7235-000A-E2311CB3CCE0}"/>
               </a:ext>
             </a:extLst>
           </p:cNvPr>
@@ -7939,8 +8558,8 @@
         </p:nvSpPr>
         <p:spPr bwMode="auto">
           <a:xfrm>
-            <a:off x="836612" y="2452536"/>
-            <a:ext cx="4928083" cy="2677656"/>
+            <a:off x="836612" y="2831521"/>
+            <a:ext cx="5374274" cy="2092881"/>
           </a:xfrm>
           <a:prstGeom prst="rect">
             <a:avLst/>
@@ -7988,31 +8607,47 @@
           </a:bodyPr>
           <a:lstStyle/>
           <a:p>
-            <a:pPr lvl="0" eaLnBrk="0" fontAlgn="base" hangingPunct="0">
+            <a:pPr marL="0" marR="0" lvl="0" indent="0" algn="l" defTabSz="914400" rtl="0" eaLnBrk="0" fontAlgn="base" latinLnBrk="0" hangingPunct="0">
+              <a:lnSpc>
+                <a:spcPct val="100000"/>
+              </a:lnSpc>
               <a:spcBef>
-                <a:spcPct val="0"/>
+                <a:spcPts val="1200"/>
               </a:spcBef>
               <a:spcAft>
                 <a:spcPct val="0"/>
               </a:spcAft>
+              <a:buClrTx/>
+              <a:buSzTx/>
               <a:buFontTx/>
               <a:buChar char="•"/>
+              <a:tabLst/>
             </a:pPr>
             <a:r>
-              <a:rPr lang="en-US" sz="2400" b="1" noProof="0" dirty="0"/>
-              <a:t>ANFIS Architecture:</a:t>
-            </a:r>
-            <a:r>
               <a:rPr lang="en-US" sz="2400" noProof="0" dirty="0"/>
-              <a:t> First-order Takagi–</a:t>
-            </a:r>
-            <a:r>
-              <a:rPr lang="en-US" sz="2400" noProof="0" dirty="0" err="1"/>
-              <a:t>Sugeno</a:t>
-            </a:r>
+              <a:t> Fuzzy rules generated via Fuzzy C-Means and Gaussian MFs initialized and rule outputs trained using Least Squares regression.</a:t>
+            </a:r>
+          </a:p>
+          <a:p>
+            <a:pPr marL="0" marR="0" lvl="0" indent="0" algn="l" defTabSz="914400" rtl="0" eaLnBrk="0" fontAlgn="base" latinLnBrk="0" hangingPunct="0">
+              <a:lnSpc>
+                <a:spcPct val="100000"/>
+              </a:lnSpc>
+              <a:spcBef>
+                <a:spcPts val="1200"/>
+              </a:spcBef>
+              <a:spcAft>
+                <a:spcPct val="0"/>
+              </a:spcAft>
+              <a:buClrTx/>
+              <a:buSzTx/>
+              <a:buFontTx/>
+              <a:buChar char="•"/>
+              <a:tabLst/>
+            </a:pPr>
             <a:r>
               <a:rPr lang="en-US" sz="2400" noProof="0" dirty="0"/>
-              <a:t>–Kang (TSK) structure with five Gaussian membership functions per input, combining fuzzy rules with linear consequents to model nonlinear relationships while maintaining interpretability.</a:t>
+              <a:t> RMSE = 0.2196; </a:t>
             </a:r>
             <a:endParaRPr kumimoji="0" lang="en-US" sz="1800" b="0" i="0" u="none" strike="noStrike" cap="none" normalizeH="0" baseline="0" noProof="0" dirty="0">
               <a:ln>
@@ -8029,10 +8664,10 @@
       </p:sp>
       <p:pic>
         <p:nvPicPr>
-          <p:cNvPr id="6" name="Picture 5" descr="A diagram of a machine learning&#10;&#10;AI-generated content may be incorrect.">
-            <a:extLst>
-              <a:ext uri="{FF2B5EF4-FFF2-40B4-BE49-F238E27FC236}">
-                <a16:creationId xmlns:a16="http://schemas.microsoft.com/office/drawing/2014/main" id="{61F93F47-AE8A-62F7-F839-88066D0965F5}"/>
+          <p:cNvPr id="13" name="Picture 12" descr="A graph with a line drawn on it&#10;&#10;AI-generated content may be incorrect.">
+            <a:extLst>
+              <a:ext uri="{FF2B5EF4-FFF2-40B4-BE49-F238E27FC236}">
+                <a16:creationId xmlns:a16="http://schemas.microsoft.com/office/drawing/2014/main" id="{8A7E7967-342C-BCCB-22A9-BBE00F9C3FF4}"/>
               </a:ext>
             </a:extLst>
           </p:cNvPr>
@@ -8055,8 +8690,8 @@
         </p:blipFill>
         <p:spPr>
           <a:xfrm>
-            <a:off x="6404679" y="1140204"/>
-            <a:ext cx="4945401" cy="5352670"/>
+            <a:off x="6557889" y="1579389"/>
+            <a:ext cx="5114021" cy="4973083"/>
           </a:xfrm>
           <a:prstGeom prst="rect">
             <a:avLst/>
@@ -8066,7 +8701,7 @@
     </p:spTree>
     <p:extLst>
       <p:ext uri="{BB962C8B-B14F-4D97-AF65-F5344CB8AC3E}">
-        <p14:creationId xmlns:p14="http://schemas.microsoft.com/office/powerpoint/2010/main" val="3720105677"/>
+        <p14:creationId xmlns:p14="http://schemas.microsoft.com/office/powerpoint/2010/main" val="3403054834"/>
       </p:ext>
     </p:extLst>
   </p:cSld>
@@ -8217,8 +8852,8 @@
         </p:nvSpPr>
         <p:spPr bwMode="auto">
           <a:xfrm>
-            <a:off x="836612" y="1707443"/>
-            <a:ext cx="5345527" cy="4893647"/>
+            <a:off x="836612" y="1502688"/>
+            <a:ext cx="5345527" cy="5355312"/>
           </a:xfrm>
           <a:prstGeom prst="rect">
             <a:avLst/>
@@ -8271,7 +8906,7 @@
                 <a:spcPct val="100000"/>
               </a:lnSpc>
               <a:spcBef>
-                <a:spcPct val="0"/>
+                <a:spcPts val="1200"/>
               </a:spcBef>
               <a:spcAft>
                 <a:spcPct val="0"/>
@@ -8293,7 +8928,7 @@
                 <a:spcPct val="100000"/>
               </a:lnSpc>
               <a:spcBef>
-                <a:spcPct val="0"/>
+                <a:spcPts val="1200"/>
               </a:spcBef>
               <a:spcAft>
                 <a:spcPct val="0"/>
@@ -8312,7 +8947,7 @@
           <a:p>
             <a:pPr eaLnBrk="0" fontAlgn="base" hangingPunct="0">
               <a:spcBef>
-                <a:spcPct val="0"/>
+                <a:spcPts val="1200"/>
               </a:spcBef>
               <a:spcAft>
                 <a:spcPct val="0"/>
@@ -8331,7 +8966,7 @@
                 <a:spcPct val="100000"/>
               </a:lnSpc>
               <a:spcBef>
-                <a:spcPct val="0"/>
+                <a:spcPts val="1200"/>
               </a:spcBef>
               <a:spcAft>
                 <a:spcPct val="0"/>

</xml_diff>